<commit_message>
Keep the workshop decks in English
Translate the chapter labels consistently across the HTML and PowerPoint decks while preserving the four-chapter structure and all 27 slides.\n\nCo-authored-by: Copilot App <223556219+Copilot@users.noreply.github.com>
</commit_message>
<xml_diff>
--- a/GitHub-Copilot-SDK.pptx
+++ b/GitHub-Copilot-SDK.pptx
@@ -5760,7 +5760,7 @@
                 <a:ea typeface="Calibri" pitchFamily="34" charset="-122"/>
                 <a:cs typeface="Calibri" pitchFamily="34" charset="-120"/>
               </a:rPr>
-              <a:t>Möglichkeiten · Capability Map</a:t>
+              <a:t>Capabilities · Capability Map</a:t>
             </a:r>
             <a:endParaRPr lang="en-US" sz="2600" dirty="0"/>
           </a:p>
@@ -6692,7 +6692,7 @@
                   <a:srgbClr val="C9D1D9"/>
                 </a:solidFill>
               </a:rPr>
-              <a:t>Möglichkeiten · Where the SDK Fits</a:t>
+              <a:t>Capabilities · Where the SDK Fits</a:t>
             </a:r>
           </a:p>
         </p:txBody>
@@ -7210,7 +7210,7 @@
                 <a:ea typeface="Calibri" pitchFamily="34" charset="-122"/>
                 <a:cs typeface="Calibri" pitchFamily="34" charset="-120"/>
               </a:rPr>
-              <a:t>Möglichkeiten · Identity Models</a:t>
+              <a:t>Capabilities · Identity Models</a:t>
             </a:r>
             <a:endParaRPr lang="en-US" sz="2600" dirty="0"/>
           </a:p>
@@ -9042,7 +9042,7 @@
                 <a:ea typeface="Calibri" pitchFamily="34" charset="-122"/>
                 <a:cs typeface="Calibri" pitchFamily="34" charset="-120"/>
               </a:rPr>
-              <a:t>Möglichkeiten · BYOK</a:t>
+              <a:t>Capabilities · BYOK</a:t>
             </a:r>
             <a:endParaRPr lang="en-US" sz="2600" dirty="0"/>
           </a:p>
@@ -13276,7 +13276,7 @@
                 </a:solidFill>
                 <a:latin typeface="Courier New"/>
               </a:rPr>
-              <a:t>    "Explain the SDK in 3 sentences.",</a:t>
+              <a:t xml:space="preserve">    "Explain the SDK in 3 sentences.",</a:t>
             </a:r>
           </a:p>
           <a:p>
@@ -13298,7 +13298,7 @@
                 </a:solidFill>
                 <a:latin typeface="Courier New"/>
               </a:rPr>
-              <a:t>    timeout=60)</a:t>
+              <a:t xml:space="preserve">    timeout=60)</a:t>
             </a:r>
           </a:p>
           <a:p>
@@ -13342,7 +13342,7 @@
                 </a:solidFill>
                 <a:latin typeface="Courier New"/>
               </a:rPr>
-              <a:t>    raise RuntimeError("No final message")</a:t>
+              <a:t xml:space="preserve">    raise RuntimeError("No final message")</a:t>
             </a:r>
           </a:p>
           <a:p>
@@ -14229,7 +14229,7 @@
                 <a:ea typeface="Calibri" pitchFamily="34" charset="-122"/>
                 <a:cs typeface="Calibri" pitchFamily="34" charset="-120"/>
               </a:rPr>
-              <a:t>01 · SDK im Detail</a:t>
+              <a:t>01 · SDK in Detail</a:t>
             </a:r>
             <a:endParaRPr lang="en-US" sz="1200" dirty="0"/>
           </a:p>
@@ -14371,7 +14371,7 @@
                 <a:ea typeface="Calibri" pitchFamily="34" charset="-122"/>
                 <a:cs typeface="Calibri" pitchFamily="34" charset="-120"/>
               </a:rPr>
-              <a:t>02 · Abgrenzung zur CLI</a:t>
+              <a:t>02 · SDK vs. CLI</a:t>
             </a:r>
             <a:endParaRPr lang="en-US" sz="1200" dirty="0"/>
           </a:p>
@@ -14513,7 +14513,7 @@
                 <a:ea typeface="Calibri" pitchFamily="34" charset="-122"/>
                 <a:cs typeface="Calibri" pitchFamily="34" charset="-120"/>
               </a:rPr>
-              <a:t>03 · Möglichkeiten</a:t>
+              <a:t>03 · Capabilities</a:t>
             </a:r>
             <a:endParaRPr lang="en-US" sz="1200" dirty="0"/>
           </a:p>
@@ -18807,7 +18807,7 @@
                 </a:solidFill>
                 <a:latin typeface="Courier New"/>
               </a:rPr>
-              <a:t>    match request:</a:t>
+              <a:t xml:space="preserve">    match request:</a:t>
             </a:r>
           </a:p>
           <a:p>
@@ -18829,7 +18829,7 @@
                 </a:solidFill>
                 <a:latin typeface="Courier New"/>
               </a:rPr>
-              <a:t>        case PermissionRequestShell(full_command_text=cmd):</a:t>
+              <a:t xml:space="preserve">        case PermissionRequestShell(full_command_text=cmd):</a:t>
             </a:r>
           </a:p>
           <a:p>
@@ -18851,7 +18851,7 @@
                 </a:solidFill>
                 <a:latin typeface="Courier New"/>
               </a:rPr>
-              <a:t>            if not is_expected_command(cmd):</a:t>
+              <a:t xml:space="preserve">            if not is_expected_command(cmd):</a:t>
             </a:r>
           </a:p>
           <a:p>
@@ -18873,7 +18873,7 @@
                 </a:solidFill>
                 <a:latin typeface="Courier New"/>
               </a:rPr>
-              <a:t>                return PermissionDecisionReject()</a:t>
+              <a:t xml:space="preserve">                return PermissionDecisionReject()</a:t>
             </a:r>
           </a:p>
           <a:p>
@@ -18895,7 +18895,7 @@
                 </a:solidFill>
                 <a:latin typeface="Courier New"/>
               </a:rPr>
-              <a:t>            answer = await read_answer(</a:t>
+              <a:t xml:space="preserve">            answer = await read_answer(</a:t>
             </a:r>
           </a:p>
           <a:p>
@@ -18917,7 +18917,7 @@
                 </a:solidFill>
                 <a:latin typeface="Courier New"/>
               </a:rPr>
-              <a:t>                "Approve once? [y/N]: ", timeout=120)</a:t>
+              <a:t xml:space="preserve">                "Approve once? [y/N]: ", timeout=120)</a:t>
             </a:r>
           </a:p>
           <a:p>
@@ -18939,7 +18939,7 @@
                 </a:solidFill>
                 <a:latin typeface="Courier New"/>
               </a:rPr>
-              <a:t>            if answer.lower() == "y":</a:t>
+              <a:t xml:space="preserve">            if answer.lower() == "y":</a:t>
             </a:r>
           </a:p>
           <a:p>
@@ -18961,7 +18961,7 @@
                 </a:solidFill>
                 <a:latin typeface="Courier New"/>
               </a:rPr>
-              <a:t>                return PermissionDecisionApproveOnce()</a:t>
+              <a:t xml:space="preserve">                return PermissionDecisionApproveOnce()</a:t>
             </a:r>
           </a:p>
           <a:p>
@@ -18983,7 +18983,7 @@
                 </a:solidFill>
                 <a:latin typeface="Courier New"/>
               </a:rPr>
-              <a:t>    return PermissionDecisionReject()</a:t>
+              <a:t xml:space="preserve">    return PermissionDecisionReject()</a:t>
             </a:r>
           </a:p>
         </p:txBody>
@@ -24236,7 +24236,7 @@
                 <a:ea typeface="Calibri" pitchFamily="34" charset="-122"/>
                 <a:cs typeface="Calibri" pitchFamily="34" charset="-120"/>
               </a:rPr>
-              <a:t>SDK im Detail · What It Is</a:t>
+              <a:t>SDK in Detail · What It Is</a:t>
             </a:r>
             <a:endParaRPr lang="en-US" sz="2600" dirty="0"/>
           </a:p>
@@ -24964,7 +24964,7 @@
                 <a:ea typeface="Calibri" pitchFamily="34" charset="-122"/>
                 <a:cs typeface="Calibri" pitchFamily="34" charset="-120"/>
               </a:rPr>
-              <a:t>SDK im Detail · Architecture</a:t>
+              <a:t>SDK in Detail · Architecture</a:t>
             </a:r>
             <a:endParaRPr lang="en-US" sz="2600" dirty="0"/>
           </a:p>
@@ -26085,7 +26085,7 @@
                 <a:ea typeface="Calibri" pitchFamily="34" charset="-122"/>
                 <a:cs typeface="Calibri" pitchFamily="34" charset="-120"/>
               </a:rPr>
-              <a:t>SDK im Detail · Client and Session Lifecycle</a:t>
+              <a:t>SDK in Detail · Client and Session Lifecycle</a:t>
             </a:r>
             <a:endParaRPr lang="en-US" sz="2600" dirty="0"/>
           </a:p>
@@ -26667,7 +26667,7 @@
                 <a:ea typeface="Calibri" pitchFamily="34" charset="-122"/>
                 <a:cs typeface="Calibri" pitchFamily="34" charset="-120"/>
               </a:rPr>
-              <a:t>SDK im Detail · Events and Streaming</a:t>
+              <a:t>SDK in Detail · Events and Streaming</a:t>
             </a:r>
             <a:endParaRPr lang="en-US" sz="2600" dirty="0"/>
           </a:p>
@@ -27530,7 +27530,7 @@
                 <a:ea typeface="Calibri" pitchFamily="34" charset="-122"/>
                 <a:cs typeface="Calibri" pitchFamily="34" charset="-120"/>
               </a:rPr>
-              <a:t>SDK im Detail · Tool and Session Surfaces</a:t>
+              <a:t>SDK in Detail · Tool and Session Surfaces</a:t>
             </a:r>
             <a:endParaRPr lang="en-US" sz="2600" dirty="0"/>
           </a:p>
@@ -28727,7 +28727,7 @@
                 </a:solidFill>
                 <a:latin typeface="Calibri"/>
               </a:rPr>
-              <a:t>SDK im Detail · Permission and Containment</a:t>
+              <a:t>SDK in Detail · Permission and Containment</a:t>
             </a:r>
           </a:p>
         </p:txBody>

</xml_diff>

<commit_message>
Distill the workshop title slide
Remove the explanatory subtitle and metadata badges from the HTML title, and remove the analogous captions and language labels from the PowerPoint title.\n\nCo-authored-by: Copilot App <223556219+Copilot@users.noreply.github.com>
</commit_message>
<xml_diff>
--- a/GitHub-Copilot-SDK.pptx
+++ b/GitHub-Copilot-SDK.pptx
@@ -2662,479 +2662,6 @@
               <a:t>GitHub Copilot SDK</a:t>
             </a:r>
             <a:endParaRPr lang="en-US" sz="4200" dirty="0"/>
-          </a:p>
-        </p:txBody>
-      </p:sp>
-      <p:sp>
-        <p:nvSpPr>
-          <p:cNvPr id="5" name="Text 2"/>
-          <p:cNvSpPr/>
-          <p:nvPr/>
-        </p:nvSpPr>
-        <p:spPr>
-          <a:xfrm>
-            <a:off x="457200" y="2423160"/>
-            <a:ext cx="8229600" cy="457200"/>
-          </a:xfrm>
-          <a:prstGeom prst="rect">
-            <a:avLst/>
-          </a:prstGeom>
-          <a:noFill/>
-          <a:ln>
-            <a:noFill/>
-          </a:ln>
-        </p:spPr>
-        <p:txBody>
-          <a:bodyPr wrap="square" lIns="0" tIns="0" rIns="0" bIns="0" rtlCol="0" anchor="ctr"/>
-          <a:lstStyle/>
-          <a:p>
-            <a:pPr marL="0" indent="0" algn="ctr">
-              <a:buNone/>
-            </a:pPr>
-            <a:r>
-              <a:rPr lang="en-US" sz="2200" i="1" dirty="0">
-                <a:solidFill>
-                  <a:srgbClr val="58A6FF"/>
-                </a:solidFill>
-                <a:latin typeface="Calibri" pitchFamily="34" charset="0"/>
-                <a:ea typeface="Calibri" pitchFamily="34" charset="-122"/>
-                <a:cs typeface="Calibri" pitchFamily="34" charset="-120"/>
-              </a:rPr>
-              <a:t>Eight verified Python patterns</a:t>
-            </a:r>
-            <a:endParaRPr lang="en-US" sz="2200" dirty="0"/>
-          </a:p>
-        </p:txBody>
-      </p:sp>
-      <p:sp>
-        <p:nvSpPr>
-          <p:cNvPr id="6" name="Text 3"/>
-          <p:cNvSpPr/>
-          <p:nvPr/>
-        </p:nvSpPr>
-        <p:spPr>
-          <a:xfrm>
-            <a:off x="1371600" y="3063240"/>
-            <a:ext cx="6400800" cy="365760"/>
-          </a:xfrm>
-          <a:prstGeom prst="rect">
-            <a:avLst/>
-          </a:prstGeom>
-          <a:noFill/>
-          <a:ln>
-            <a:noFill/>
-          </a:ln>
-        </p:spPr>
-        <p:txBody>
-          <a:bodyPr wrap="square" lIns="0" tIns="0" rIns="0" bIns="0" rtlCol="0" anchor="ctr"/>
-          <a:lstStyle/>
-          <a:p>
-            <a:pPr marL="0" indent="0" algn="ctr">
-              <a:buNone/>
-            </a:pPr>
-            <a:r>
-              <a:rPr lang="en-US" sz="1400" dirty="0">
-                <a:solidFill>
-                  <a:srgbClr val="8B949E"/>
-                </a:solidFill>
-                <a:latin typeface="Calibri" pitchFamily="34" charset="0"/>
-                <a:ea typeface="Calibri" pitchFamily="34" charset="-122"/>
-                <a:cs typeface="Calibri" pitchFamily="34" charset="-120"/>
-              </a:rPr>
-              <a:t>From a bounded first response to MCP, HITL, persistence, and sandboxing</a:t>
-            </a:r>
-            <a:endParaRPr lang="en-US" sz="1400" dirty="0"/>
-          </a:p>
-        </p:txBody>
-      </p:sp>
-      <p:sp>
-        <p:nvSpPr>
-          <p:cNvPr id="7" name="Shape 4"/>
-          <p:cNvSpPr/>
-          <p:nvPr/>
-        </p:nvSpPr>
-        <p:spPr>
-          <a:xfrm>
-            <a:off x="1463040" y="3749040"/>
-            <a:ext cx="1097280" cy="320040"/>
-          </a:xfrm>
-          <a:prstGeom prst="line">
-            <a:avLst/>
-          </a:prstGeom>
-          <a:solidFill>
-            <a:srgbClr val="161B22"/>
-          </a:solidFill>
-          <a:ln w="12700">
-            <a:prstDash val="solid"/>
-          </a:ln>
-        </p:spPr>
-        <p:txBody>
-          <a:bodyPr/>
-          <a:lstStyle/>
-          <a:p>
-            <a:endParaRPr/>
-          </a:p>
-        </p:txBody>
-      </p:sp>
-      <p:sp>
-        <p:nvSpPr>
-          <p:cNvPr id="8" name="Text 5"/>
-          <p:cNvSpPr/>
-          <p:nvPr/>
-        </p:nvSpPr>
-        <p:spPr>
-          <a:xfrm>
-            <a:off x="1463040" y="3749040"/>
-            <a:ext cx="1097280" cy="320040"/>
-          </a:xfrm>
-          <a:prstGeom prst="rect">
-            <a:avLst/>
-          </a:prstGeom>
-          <a:noFill/>
-          <a:ln>
-            <a:noFill/>
-          </a:ln>
-        </p:spPr>
-        <p:txBody>
-          <a:bodyPr wrap="square" lIns="0" tIns="0" rIns="0" bIns="0" rtlCol="0" anchor="ctr"/>
-          <a:lstStyle/>
-          <a:p>
-            <a:pPr marL="0" indent="0" algn="ctr">
-              <a:buNone/>
-            </a:pPr>
-            <a:r>
-              <a:rPr lang="en-US" sz="1100" dirty="0">
-                <a:solidFill>
-                  <a:srgbClr val="C9D1D9"/>
-                </a:solidFill>
-                <a:latin typeface="Calibri" pitchFamily="34" charset="0"/>
-                <a:ea typeface="Calibri" pitchFamily="34" charset="-122"/>
-                <a:cs typeface="Calibri" pitchFamily="34" charset="-120"/>
-              </a:rPr>
-              <a:t>TypeScript</a:t>
-            </a:r>
-            <a:endParaRPr lang="en-US" sz="1100" dirty="0"/>
-          </a:p>
-        </p:txBody>
-      </p:sp>
-      <p:sp>
-        <p:nvSpPr>
-          <p:cNvPr id="9" name="Shape 6"/>
-          <p:cNvSpPr/>
-          <p:nvPr/>
-        </p:nvSpPr>
-        <p:spPr>
-          <a:xfrm>
-            <a:off x="2697480" y="3749040"/>
-            <a:ext cx="1097280" cy="320040"/>
-          </a:xfrm>
-          <a:prstGeom prst="line">
-            <a:avLst/>
-          </a:prstGeom>
-          <a:solidFill>
-            <a:srgbClr val="161B22"/>
-          </a:solidFill>
-          <a:ln w="12700">
-            <a:prstDash val="solid"/>
-          </a:ln>
-        </p:spPr>
-        <p:txBody>
-          <a:bodyPr/>
-          <a:lstStyle/>
-          <a:p>
-            <a:endParaRPr/>
-          </a:p>
-        </p:txBody>
-      </p:sp>
-      <p:sp>
-        <p:nvSpPr>
-          <p:cNvPr id="10" name="Text 7"/>
-          <p:cNvSpPr/>
-          <p:nvPr/>
-        </p:nvSpPr>
-        <p:spPr>
-          <a:xfrm>
-            <a:off x="2697480" y="3749040"/>
-            <a:ext cx="1097280" cy="320040"/>
-          </a:xfrm>
-          <a:prstGeom prst="rect">
-            <a:avLst/>
-          </a:prstGeom>
-          <a:noFill/>
-          <a:ln>
-            <a:noFill/>
-          </a:ln>
-        </p:spPr>
-        <p:txBody>
-          <a:bodyPr wrap="square" lIns="0" tIns="0" rIns="0" bIns="0" rtlCol="0" anchor="ctr"/>
-          <a:lstStyle/>
-          <a:p>
-            <a:pPr marL="0" indent="0" algn="ctr">
-              <a:buNone/>
-            </a:pPr>
-            <a:r>
-              <a:rPr lang="en-US" sz="1100" dirty="0">
-                <a:solidFill>
-                  <a:srgbClr val="C9D1D9"/>
-                </a:solidFill>
-                <a:latin typeface="Calibri" pitchFamily="34" charset="0"/>
-                <a:ea typeface="Calibri" pitchFamily="34" charset="-122"/>
-                <a:cs typeface="Calibri" pitchFamily="34" charset="-120"/>
-              </a:rPr>
-              <a:t>Python</a:t>
-            </a:r>
-            <a:endParaRPr lang="en-US" sz="1100" dirty="0"/>
-          </a:p>
-        </p:txBody>
-      </p:sp>
-      <p:sp>
-        <p:nvSpPr>
-          <p:cNvPr id="11" name="Shape 8"/>
-          <p:cNvSpPr/>
-          <p:nvPr/>
-        </p:nvSpPr>
-        <p:spPr>
-          <a:xfrm>
-            <a:off x="3931920" y="3749040"/>
-            <a:ext cx="1097280" cy="320040"/>
-          </a:xfrm>
-          <a:prstGeom prst="line">
-            <a:avLst/>
-          </a:prstGeom>
-          <a:solidFill>
-            <a:srgbClr val="161B22"/>
-          </a:solidFill>
-          <a:ln w="12700">
-            <a:prstDash val="solid"/>
-          </a:ln>
-        </p:spPr>
-        <p:txBody>
-          <a:bodyPr/>
-          <a:lstStyle/>
-          <a:p>
-            <a:endParaRPr/>
-          </a:p>
-        </p:txBody>
-      </p:sp>
-      <p:sp>
-        <p:nvSpPr>
-          <p:cNvPr id="12" name="Text 9"/>
-          <p:cNvSpPr/>
-          <p:nvPr/>
-        </p:nvSpPr>
-        <p:spPr>
-          <a:xfrm>
-            <a:off x="3931920" y="3749040"/>
-            <a:ext cx="1097280" cy="320040"/>
-          </a:xfrm>
-          <a:prstGeom prst="rect">
-            <a:avLst/>
-          </a:prstGeom>
-          <a:noFill/>
-          <a:ln>
-            <a:noFill/>
-          </a:ln>
-        </p:spPr>
-        <p:txBody>
-          <a:bodyPr wrap="square" lIns="0" tIns="0" rIns="0" bIns="0" rtlCol="0" anchor="ctr"/>
-          <a:lstStyle/>
-          <a:p>
-            <a:pPr marL="0" indent="0" algn="ctr">
-              <a:buNone/>
-            </a:pPr>
-            <a:r>
-              <a:rPr lang="en-US" sz="1100" dirty="0">
-                <a:solidFill>
-                  <a:srgbClr val="C9D1D9"/>
-                </a:solidFill>
-                <a:latin typeface="Calibri" pitchFamily="34" charset="0"/>
-                <a:ea typeface="Calibri" pitchFamily="34" charset="-122"/>
-                <a:cs typeface="Calibri" pitchFamily="34" charset="-120"/>
-              </a:rPr>
-              <a:t>Go</a:t>
-            </a:r>
-            <a:endParaRPr lang="en-US" sz="1100" dirty="0"/>
-          </a:p>
-        </p:txBody>
-      </p:sp>
-      <p:sp>
-        <p:nvSpPr>
-          <p:cNvPr id="13" name="Shape 10"/>
-          <p:cNvSpPr/>
-          <p:nvPr/>
-        </p:nvSpPr>
-        <p:spPr>
-          <a:xfrm>
-            <a:off x="5166360" y="3749040"/>
-            <a:ext cx="1097280" cy="320040"/>
-          </a:xfrm>
-          <a:prstGeom prst="line">
-            <a:avLst/>
-          </a:prstGeom>
-          <a:solidFill>
-            <a:srgbClr val="161B22"/>
-          </a:solidFill>
-          <a:ln w="12700">
-            <a:prstDash val="solid"/>
-          </a:ln>
-        </p:spPr>
-        <p:txBody>
-          <a:bodyPr/>
-          <a:lstStyle/>
-          <a:p>
-            <a:endParaRPr/>
-          </a:p>
-        </p:txBody>
-      </p:sp>
-      <p:sp>
-        <p:nvSpPr>
-          <p:cNvPr id="14" name="Text 11"/>
-          <p:cNvSpPr/>
-          <p:nvPr/>
-        </p:nvSpPr>
-        <p:spPr>
-          <a:xfrm>
-            <a:off x="5166360" y="3749040"/>
-            <a:ext cx="1097280" cy="320040"/>
-          </a:xfrm>
-          <a:prstGeom prst="rect">
-            <a:avLst/>
-          </a:prstGeom>
-          <a:noFill/>
-          <a:ln>
-            <a:noFill/>
-          </a:ln>
-        </p:spPr>
-        <p:txBody>
-          <a:bodyPr wrap="square" lIns="0" tIns="0" rIns="0" bIns="0" rtlCol="0" anchor="ctr"/>
-          <a:lstStyle/>
-          <a:p>
-            <a:pPr marL="0" indent="0" algn="ctr">
-              <a:buNone/>
-            </a:pPr>
-            <a:r>
-              <a:rPr lang="en-US" sz="1100" dirty="0">
-                <a:solidFill>
-                  <a:srgbClr val="C9D1D9"/>
-                </a:solidFill>
-                <a:latin typeface="Calibri" pitchFamily="34" charset="0"/>
-                <a:ea typeface="Calibri" pitchFamily="34" charset="-122"/>
-                <a:cs typeface="Calibri" pitchFamily="34" charset="-120"/>
-              </a:rPr>
-              <a:t>.NET</a:t>
-            </a:r>
-            <a:endParaRPr lang="en-US" sz="1100" dirty="0"/>
-          </a:p>
-        </p:txBody>
-      </p:sp>
-      <p:sp>
-        <p:nvSpPr>
-          <p:cNvPr id="15" name="Shape 12"/>
-          <p:cNvSpPr/>
-          <p:nvPr/>
-        </p:nvSpPr>
-        <p:spPr>
-          <a:xfrm>
-            <a:off x="6400800" y="3749040"/>
-            <a:ext cx="1097280" cy="320040"/>
-          </a:xfrm>
-          <a:prstGeom prst="line">
-            <a:avLst/>
-          </a:prstGeom>
-          <a:solidFill>
-            <a:srgbClr val="161B22"/>
-          </a:solidFill>
-          <a:ln w="12700">
-            <a:prstDash val="solid"/>
-          </a:ln>
-        </p:spPr>
-        <p:txBody>
-          <a:bodyPr/>
-          <a:lstStyle/>
-          <a:p>
-            <a:endParaRPr/>
-          </a:p>
-        </p:txBody>
-      </p:sp>
-      <p:sp>
-        <p:nvSpPr>
-          <p:cNvPr id="16" name="Text 13"/>
-          <p:cNvSpPr/>
-          <p:nvPr/>
-        </p:nvSpPr>
-        <p:spPr>
-          <a:xfrm>
-            <a:off x="6400800" y="3749040"/>
-            <a:ext cx="1097280" cy="320040"/>
-          </a:xfrm>
-          <a:prstGeom prst="rect">
-            <a:avLst/>
-          </a:prstGeom>
-          <a:noFill/>
-          <a:ln>
-            <a:noFill/>
-          </a:ln>
-        </p:spPr>
-        <p:txBody>
-          <a:bodyPr wrap="square" lIns="0" tIns="0" rIns="0" bIns="0" rtlCol="0" anchor="ctr"/>
-          <a:lstStyle/>
-          <a:p>
-            <a:pPr marL="0" indent="0" algn="ctr">
-              <a:buNone/>
-            </a:pPr>
-            <a:r>
-              <a:rPr lang="en-US" sz="1100" dirty="0">
-                <a:solidFill>
-                  <a:srgbClr val="C9D1D9"/>
-                </a:solidFill>
-                <a:latin typeface="Calibri" pitchFamily="34" charset="0"/>
-                <a:ea typeface="Calibri" pitchFamily="34" charset="-122"/>
-                <a:cs typeface="Calibri" pitchFamily="34" charset="-120"/>
-              </a:rPr>
-              <a:t>Java / Rust</a:t>
-            </a:r>
-            <a:endParaRPr lang="en-US" sz="1100" dirty="0"/>
-          </a:p>
-        </p:txBody>
-      </p:sp>
-      <p:sp>
-        <p:nvSpPr>
-          <p:cNvPr id="17" name="Text 14"/>
-          <p:cNvSpPr/>
-          <p:nvPr/>
-        </p:nvSpPr>
-        <p:spPr>
-          <a:xfrm>
-            <a:off x="3383280" y="4297680"/>
-            <a:ext cx="2377440" cy="274320"/>
-          </a:xfrm>
-          <a:prstGeom prst="rect">
-            <a:avLst/>
-          </a:prstGeom>
-          <a:noFill/>
-          <a:ln>
-            <a:noFill/>
-          </a:ln>
-        </p:spPr>
-        <p:txBody>
-          <a:bodyPr wrap="square" lIns="0" tIns="0" rIns="0" bIns="0" rtlCol="0" anchor="ctr"/>
-          <a:lstStyle/>
-          <a:p>
-            <a:pPr marL="0" indent="0" algn="ctr">
-              <a:buNone/>
-            </a:pPr>
-            <a:r>
-              <a:rPr lang="en-US" sz="1000" dirty="0">
-                <a:solidFill>
-                  <a:srgbClr val="F0883E"/>
-                </a:solidFill>
-                <a:latin typeface="Calibri" pitchFamily="34" charset="0"/>
-                <a:ea typeface="Calibri" pitchFamily="34" charset="-122"/>
-                <a:cs typeface="Calibri" pitchFamily="34" charset="-120"/>
-              </a:rPr>
-              <a:t>Stable · SDK 1.0.13 · runtime 1.0.83</a:t>
-            </a:r>
-            <a:endParaRPr lang="en-US" sz="1000" dirty="0"/>
           </a:p>
         </p:txBody>
       </p:sp>

</xml_diff>

<commit_message>
Rewrite workshop copy for technical audiences
Replace slogans and presenter-meta with concrete SDK contracts, runtime behavior, security boundaries, and sample outcomes. Repair the affected PowerPoint layouts and turn the closing slide into an implementation checklist.\n\nCo-authored-by: Copilot App <223556219+Copilot@users.noreply.github.com>
</commit_message>
<xml_diff>
--- a/GitHub-Copilot-SDK.pptx
+++ b/GitHub-Copilot-SDK.pptx
@@ -4092,7 +4092,7 @@
                 <a:ea typeface="Calibri" pitchFamily="34" charset="-122"/>
                 <a:cs typeface="Calibri" pitchFamily="34" charset="-120"/>
               </a:rPr>
-              <a:t>CLI vs SDK · Production Consequences</a:t>
+              <a:t>CLI vs SDK · Host Responsibilities</a:t>
             </a:r>
             <a:endParaRPr lang="en-US" sz="2600" dirty="0"/>
           </a:p>
@@ -6018,7 +6018,7 @@
                 <a:ea typeface="Calibri" pitchFamily="34" charset="-122"/>
                 <a:cs typeface="Calibri" pitchFamily="34" charset="-120"/>
               </a:rPr>
-              <a:t>Capabilities are modular. Enable only combinations your product can support safely.</a:t>
+              <a:t>Each API is independent; enable it only with the required host controls.</a:t>
             </a:r>
             <a:endParaRPr lang="en-US" sz="1000" dirty="0"/>
           </a:p>
@@ -6219,7 +6219,7 @@
                   <a:srgbClr val="C9D1D9"/>
                 </a:solidFill>
               </a:rPr>
-              <a:t>Capabilities · Where the SDK Fits</a:t>
+              <a:t>Capabilities · Integration Targets</a:t>
             </a:r>
           </a:p>
         </p:txBody>
@@ -6252,7 +6252,7 @@
                   <a:srgbClr val="8B949E"/>
                 </a:solidFill>
               </a:rPr>
-              <a:t>Use the SDK when the agent must live inside another product or workflow; then choose identity and provider boundaries</a:t>
+              <a:t>Use the SDK when an application owns the UI, session lifecycle, or automated workflow.</a:t>
             </a:r>
           </a:p>
         </p:txBody>
@@ -6476,7 +6476,7 @@
                   <a:srgbClr val="58A6FF"/>
                 </a:solidFill>
               </a:rPr>
-              <a:t>Choose the surface deliberately</a:t>
+              <a:t>Interface boundary</a:t>
             </a:r>
           </a:p>
           <a:p>
@@ -6608,7 +6608,7 @@
                   <a:srgbClr val="C9D1D9"/>
                 </a:solidFill>
               </a:rPr>
-              <a:t xml:space="preserve">Production boundaries remain host responsibilities</a:t>
+              <a:t xml:space="preserve">Identity, isolation, routing, and limits remain host responsibilities</a:t>
             </a:r>
             <a:r>
               <a:rPr sz="1300" b="0" dirty="0" err="1">
@@ -7336,7 +7336,18 @@
                     <a:bodyPr/>
                     <a:lstStyle/>
                     <a:p>
+                      <a:pPr>
+                        <a:lnSpc>
+                          <a:spcPct val="100000"/>
+                        </a:lnSpc>
+                      </a:pPr>
                       <a:r>
+                        <a:rPr sz="1150" b="0">
+                          <a:solidFill>
+                            <a:srgbClr val="E6EDF3"/>
+                          </a:solidFill>
+                          <a:latin typeface="Calibri"/>
+                        </a:rPr>
                         <a:t>User entitlement + applicable organization policy</a:t>
                       </a:r>
                     </a:p>
@@ -7793,7 +7804,7 @@
         </p:nvSpPr>
         <p:spPr>
           <a:xfrm>
-            <a:off x="548640" y="3310128"/>
+            <a:off x="548640" y="3429000"/>
             <a:ext cx="8046720" cy="365760"/>
           </a:xfrm>
           <a:prstGeom prst="rect">
@@ -8634,7 +8645,7 @@
                 <a:ea typeface="Calibri" pitchFamily="34" charset="-122"/>
                 <a:cs typeface="Calibri" pitchFamily="34" charset="-120"/>
               </a:rPr>
-              <a:t>Your provider, model, billing, residency, and access policy; keys are optional</a:t>
+              <a:t>ProviderConfig defines endpoint, protocol, model, and authentication; inference billing follows that provider</a:t>
             </a:r>
             <a:endParaRPr lang="en-US" sz="1200" dirty="0"/>
           </a:p>
@@ -10124,7 +10135,7 @@
                 <a:ea typeface="Calibri" pitchFamily="34" charset="-122"/>
                 <a:cs typeface="Calibri" pitchFamily="34" charset="-120"/>
               </a:rPr>
-              <a:t>Samples · Get to Green</a:t>
+              <a:t>Samples · Environment Check</a:t>
             </a:r>
             <a:endParaRPr lang="en-US" sz="2600" dirty="0"/>
           </a:p>
@@ -11025,7 +11036,7 @@
                 <a:ea typeface="Calibri" pitchFamily="34" charset="-122"/>
                 <a:cs typeface="Calibri" pitchFamily="34" charset="-120"/>
               </a:rPr>
-              <a:t>Samples · Learning Map</a:t>
+              <a:t>Samples · API Map</a:t>
             </a:r>
             <a:endParaRPr lang="en-US" sz="2600" dirty="0"/>
           </a:p>
@@ -11978,7 +11989,7 @@
                 <a:ea typeface="Calibri" pitchFamily="34" charset="-122"/>
                 <a:cs typeface="Calibri" pitchFamily="34" charset="-120"/>
               </a:rPr>
-              <a:t>07 · Human control</a:t>
+              <a:t>07 · Human approval</a:t>
             </a:r>
             <a:endParaRPr lang="en-US" sz="1200" dirty="0"/>
           </a:p>
@@ -12341,7 +12352,7 @@
                 <a:ea typeface="Calibri" pitchFamily="34" charset="-122"/>
                 <a:cs typeface="Calibri" pitchFamily="34" charset="-120"/>
               </a:rPr>
-              <a:t>Typed deltas for output; send_and_wait for bounded completion and propagated errors</a:t>
+              <a:t>Typed deltas stream output; send_and_wait handles timeout, error, and idle states</a:t>
             </a:r>
             <a:endParaRPr lang="en-US" sz="1200" dirty="0"/>
           </a:p>
@@ -13655,7 +13666,7 @@
                 <a:ea typeface="Calibri" pitchFamily="34" charset="-122"/>
                 <a:cs typeface="Calibri" pitchFamily="34" charset="-120"/>
               </a:rPr>
-              <a:t>Four-Chapter Agenda</a:t>
+              <a:t>Agenda</a:t>
             </a:r>
             <a:endParaRPr lang="en-US" sz="2600" dirty="0"/>
           </a:p>
@@ -13939,7 +13950,7 @@
                 <a:ea typeface="Calibri" pitchFamily="34" charset="-122"/>
                 <a:cs typeface="Calibri" pitchFamily="34" charset="-120"/>
               </a:rPr>
-              <a:t>Same engine, different surface and ownership</a:t>
+              <a:t>Shared runtime; different UI, lifecycle, and ownership</a:t>
             </a:r>
             <a:endParaRPr lang="en-US" sz="950" dirty="0"/>
           </a:p>
@@ -14081,7 +14092,7 @@
                 <a:ea typeface="Calibri" pitchFamily="34" charset="-122"/>
                 <a:cs typeface="Calibri" pitchFamily="34" charset="-120"/>
               </a:rPr>
-              <a:t>Products, automation, services, and providers</a:t>
+              <a:t>Tools, agents, MCP, persistence, HITL, sandbox, and BYOK</a:t>
             </a:r>
             <a:endParaRPr lang="en-US" sz="950" dirty="0"/>
           </a:p>
@@ -14223,7 +14234,7 @@
                 <a:ea typeface="Calibri" pitchFamily="34" charset="-122"/>
                 <a:cs typeface="Calibri" pitchFamily="34" charset="-120"/>
               </a:rPr>
-              <a:t>Setup, map, and all eight runnable examples</a:t>
+              <a:t>Environment setup and eight executable Python examples</a:t>
             </a:r>
             <a:endParaRPr lang="en-US" sz="950" dirty="0"/>
           </a:p>
@@ -15168,8 +15179,8 @@
         </p:nvSpPr>
         <p:spPr>
           <a:xfrm>
-            <a:off x="731520" y="2606040"/>
-            <a:ext cx="2194560" cy="731520"/>
+            <a:off x="685800" y="2606040"/>
+            <a:ext cx="2286000" cy="731520"/>
           </a:xfrm>
           <a:prstGeom prst="rect">
             <a:avLst/>
@@ -15184,10 +15195,13 @@
           <a:lstStyle/>
           <a:p>
             <a:pPr marL="0" indent="0">
+              <a:lnSpc>
+                <a:spcPct val="100000"/>
+              </a:lnSpc>
               <a:buNone/>
             </a:pPr>
             <a:r>
-              <a:rPr lang="en-US" sz="1000" i="1" dirty="0">
+              <a:rPr lang="en-US" sz="950" i="1" dirty="0">
                 <a:solidFill>
                   <a:srgbClr val="C9D1D9"/>
                 </a:solidFill>
@@ -15195,9 +15209,9 @@
                 <a:ea typeface="Calibri" pitchFamily="34" charset="-122"/>
                 <a:cs typeface="Calibri" pitchFamily="34" charset="-120"/>
               </a:rPr>
-              <a:t>Analyze code, answer questions. Read-only.</a:t>
-            </a:r>
-            <a:endParaRPr lang="en-US" sz="1000" dirty="0"/>
+              <a:t>Analyze code, answer questions. Read‑only.</a:t>
+            </a:r>
+            <a:endParaRPr lang="en-US" sz="950" dirty="0"/>
           </a:p>
         </p:txBody>
       </p:sp>
@@ -15352,7 +15366,7 @@
         <p:spPr>
           <a:xfrm>
             <a:off x="4087368" y="2286000"/>
-            <a:ext cx="1645920" cy="228600"/>
+            <a:ext cx="1783080" cy="228600"/>
           </a:xfrm>
           <a:prstGeom prst="rect">
             <a:avLst/>
@@ -15363,14 +15377,17 @@
           </a:ln>
         </p:spPr>
         <p:txBody>
-          <a:bodyPr wrap="square" lIns="0" tIns="0" rIns="0" bIns="0" rtlCol="0" anchor="ctr"/>
+          <a:bodyPr wrap="none" lIns="0" tIns="0" rIns="0" bIns="0" rtlCol="0" anchor="ctr"/>
           <a:lstStyle/>
           <a:p>
             <a:pPr marL="0" indent="0">
+              <a:lnSpc>
+                <a:spcPct val="100000"/>
+              </a:lnSpc>
               <a:buNone/>
             </a:pPr>
             <a:r>
-              <a:rPr lang="en-US" sz="900" dirty="0">
+              <a:rPr lang="en-US" sz="850" dirty="0">
                 <a:solidFill>
                   <a:srgbClr val="3FB950"/>
                 </a:solidFill>
@@ -15380,7 +15397,7 @@
               </a:rPr>
               <a:t>agent.select(AgentSelectRequest(...))</a:t>
             </a:r>
-            <a:endParaRPr lang="en-US" sz="900" dirty="0"/>
+            <a:endParaRPr lang="en-US" sz="850" dirty="0"/>
           </a:p>
         </p:txBody>
       </p:sp>
@@ -17084,8 +17101,8 @@
         </p:nvSpPr>
         <p:spPr>
           <a:xfrm>
-            <a:off x="685800" y="2926080"/>
-            <a:ext cx="7772400" cy="1691640"/>
+            <a:off x="685800" y="2880360"/>
+            <a:ext cx="7772400" cy="1828800"/>
           </a:xfrm>
           <a:prstGeom prst="rect">
             <a:avLst/>
@@ -17101,7 +17118,7 @@
           <a:p>
             <a:pPr algn="l">
               <a:lnSpc>
-                <a:spcPct val="112000"/>
+                <a:spcPct val="100000"/>
               </a:lnSpc>
               <a:spcBef>
                 <a:spcPts val="0"/>
@@ -17111,7 +17128,7 @@
               </a:spcAft>
             </a:pPr>
             <a:r>
-              <a:rPr sz="1150" b="0">
+              <a:rPr sz="1000" b="0">
                 <a:solidFill>
                   <a:srgbClr val="E6EDF3"/>
                 </a:solidFill>
@@ -17123,7 +17140,7 @@
           <a:p>
             <a:pPr>
               <a:lnSpc>
-                <a:spcPct val="112000"/>
+                <a:spcPct val="100000"/>
               </a:lnSpc>
               <a:spcBef>
                 <a:spcPts val="0"/>
@@ -17133,7 +17150,7 @@
               </a:spcAft>
             </a:pPr>
             <a:r>
-              <a:rPr sz="1150" b="0">
+              <a:rPr sz="1000" b="0">
                 <a:solidFill>
                   <a:srgbClr val="E6EDF3"/>
                 </a:solidFill>
@@ -17145,7 +17162,7 @@
           <a:p>
             <a:pPr>
               <a:lnSpc>
-                <a:spcPct val="112000"/>
+                <a:spcPct val="100000"/>
               </a:lnSpc>
               <a:spcBef>
                 <a:spcPts val="0"/>
@@ -17155,7 +17172,7 @@
               </a:spcAft>
             </a:pPr>
             <a:r>
-              <a:rPr sz="1150" b="0">
+              <a:rPr sz="1000" b="0">
                 <a:solidFill>
                   <a:srgbClr val="E6EDF3"/>
                 </a:solidFill>
@@ -17167,7 +17184,7 @@
           <a:p>
             <a:pPr>
               <a:lnSpc>
-                <a:spcPct val="112000"/>
+                <a:spcPct val="100000"/>
               </a:lnSpc>
               <a:spcBef>
                 <a:spcPts val="0"/>
@@ -17177,7 +17194,7 @@
               </a:spcAft>
             </a:pPr>
             <a:r>
-              <a:rPr sz="1150" b="0">
+              <a:rPr sz="1000" b="0">
                 <a:solidFill>
                   <a:srgbClr val="E6EDF3"/>
                 </a:solidFill>
@@ -17189,7 +17206,7 @@
           <a:p>
             <a:pPr>
               <a:lnSpc>
-                <a:spcPct val="112000"/>
+                <a:spcPct val="100000"/>
               </a:lnSpc>
               <a:spcBef>
                 <a:spcPts val="0"/>
@@ -17199,7 +17216,7 @@
               </a:spcAft>
             </a:pPr>
             <a:r>
-              <a:rPr sz="1150" b="0">
+              <a:rPr sz="1000" b="0">
                 <a:solidFill>
                   <a:srgbClr val="E6EDF3"/>
                 </a:solidFill>
@@ -17211,7 +17228,7 @@
           <a:p>
             <a:pPr>
               <a:lnSpc>
-                <a:spcPct val="112000"/>
+                <a:spcPct val="100000"/>
               </a:lnSpc>
               <a:spcBef>
                 <a:spcPts val="0"/>
@@ -17221,7 +17238,7 @@
               </a:spcAft>
             </a:pPr>
             <a:r>
-              <a:rPr sz="1150" b="0">
+              <a:rPr sz="1000" b="0">
                 <a:solidFill>
                   <a:srgbClr val="E6EDF3"/>
                 </a:solidFill>
@@ -17233,7 +17250,7 @@
           <a:p>
             <a:pPr>
               <a:lnSpc>
-                <a:spcPct val="112000"/>
+                <a:spcPct val="100000"/>
               </a:lnSpc>
               <a:spcBef>
                 <a:spcPts val="0"/>
@@ -17243,7 +17260,7 @@
               </a:spcAft>
             </a:pPr>
             <a:r>
-              <a:rPr sz="1150" b="0">
+              <a:rPr sz="1000" b="0">
                 <a:solidFill>
                   <a:srgbClr val="E6EDF3"/>
                 </a:solidFill>
@@ -17255,7 +17272,7 @@
           <a:p>
             <a:pPr>
               <a:lnSpc>
-                <a:spcPct val="112000"/>
+                <a:spcPct val="100000"/>
               </a:lnSpc>
               <a:spcBef>
                 <a:spcPts val="0"/>
@@ -17265,7 +17282,7 @@
               </a:spcAft>
             </a:pPr>
             <a:r>
-              <a:rPr sz="1150" b="0">
+              <a:rPr sz="1000" b="0">
                 <a:solidFill>
                   <a:srgbClr val="E6EDF3"/>
                 </a:solidFill>
@@ -17277,7 +17294,7 @@
           <a:p>
             <a:pPr>
               <a:lnSpc>
-                <a:spcPct val="112000"/>
+                <a:spcPct val="100000"/>
               </a:lnSpc>
               <a:spcBef>
                 <a:spcPts val="0"/>
@@ -17287,7 +17304,7 @@
               </a:spcAft>
             </a:pPr>
             <a:r>
-              <a:rPr sz="1150" b="0">
+              <a:rPr sz="1000" b="0">
                 <a:solidFill>
                   <a:srgbClr val="E6EDF3"/>
                 </a:solidFill>
@@ -17299,7 +17316,7 @@
           <a:p>
             <a:pPr>
               <a:lnSpc>
-                <a:spcPct val="112000"/>
+                <a:spcPct val="100000"/>
               </a:lnSpc>
               <a:spcBef>
                 <a:spcPts val="0"/>
@@ -17309,7 +17326,7 @@
               </a:spcAft>
             </a:pPr>
             <a:r>
-              <a:rPr sz="1150" b="0">
+              <a:rPr sz="1000" b="0">
                 <a:solidFill>
                   <a:srgbClr val="E6EDF3"/>
                 </a:solidFill>
@@ -17321,7 +17338,7 @@
           <a:p>
             <a:pPr>
               <a:lnSpc>
-                <a:spcPct val="112000"/>
+                <a:spcPct val="100000"/>
               </a:lnSpc>
               <a:spcBef>
                 <a:spcPts val="0"/>
@@ -17331,7 +17348,7 @@
               </a:spcAft>
             </a:pPr>
             <a:r>
-              <a:rPr sz="1150" b="0">
+              <a:rPr sz="1000" b="0">
                 <a:solidFill>
                   <a:srgbClr val="E6EDF3"/>
                 </a:solidFill>
@@ -17516,7 +17533,7 @@
                 <a:ea typeface="Calibri" pitchFamily="34" charset="-122"/>
                 <a:cs typeface="Calibri" pitchFamily="34" charset="-120"/>
               </a:rPr>
-              <a:t>New process, same persisted conversation context; host configuration must be supplied again</a:t>
+              <a:t>resume_session restores persisted context; host callbacks, tools, and credentials must be supplied again</a:t>
             </a:r>
             <a:endParaRPr lang="en-US" sz="1200" dirty="0"/>
           </a:p>
@@ -18668,7 +18685,7 @@
                 </a:solidFill>
                 <a:latin typeface="Calibri"/>
               </a:rPr>
-              <a:t>Experimental and backend-dependent; the sample enables containment before requesting one bypass</a:t>
+              <a:t>Configure filesystem and network policy before allowing one explicit bypass</a:t>
             </a:r>
           </a:p>
         </p:txBody>
@@ -19675,13 +19692,13 @@
               </a:spcAft>
             </a:pPr>
             <a:r>
-              <a:rPr sz="1050" b="1" i="0">
+              <a:rPr sz="900" b="1" i="0">
                 <a:solidFill>
                   <a:srgbClr val="E6EDF3"/>
                 </a:solidFill>
-                <a:latin typeface="Consolas"/>
-              </a:rPr>
-              <a:t>Runtime tools</a:t>
+                <a:latin typeface="Calibri"/>
+              </a:rPr>
+              <a:t>Runtime</a:t>
             </a:r>
           </a:p>
         </p:txBody>
@@ -19765,13 +19782,13 @@
               </a:spcAft>
             </a:pPr>
             <a:r>
-              <a:rPr sz="1050" b="1" i="0">
+              <a:rPr sz="900" b="1" i="0">
                 <a:solidFill>
                   <a:srgbClr val="E6EDF3"/>
                 </a:solidFill>
-                <a:latin typeface="Consolas"/>
-              </a:rPr>
-              <a:t>Host tools</a:t>
+                <a:latin typeface="Calibri"/>
+              </a:rPr>
+              <a:t>Host</a:t>
             </a:r>
           </a:p>
         </p:txBody>
@@ -19855,11 +19872,11 @@
               </a:spcAft>
             </a:pPr>
             <a:r>
-              <a:rPr sz="1050" b="1" i="0">
+              <a:rPr sz="900" b="1" i="0">
                 <a:solidFill>
                   <a:srgbClr val="E6EDF3"/>
                 </a:solidFill>
-                <a:latin typeface="Consolas"/>
+                <a:latin typeface="Calibri"/>
               </a:rPr>
               <a:t>Experimental</a:t>
             </a:r>
@@ -19945,11 +19962,11 @@
               </a:spcAft>
             </a:pPr>
             <a:r>
-              <a:rPr sz="1050" b="1" i="0">
+              <a:rPr sz="900" b="1" i="0">
                 <a:solidFill>
                   <a:srgbClr val="E6EDF3"/>
                 </a:solidFill>
-                <a:latin typeface="Consolas"/>
+                <a:latin typeface="Calibri"/>
               </a:rPr>
               <a:t>Evidence</a:t>
             </a:r>
@@ -19996,7 +20013,7 @@
                 </a:solidFill>
                 <a:latin typeface="Calibri"/>
               </a:rPr>
-              <a:t>Correlate request + result</a:t>
+              <a:t>Correlate approval + tool-call ID + success</a:t>
             </a:r>
           </a:p>
         </p:txBody>
@@ -20035,11 +20052,11 @@
               </a:spcAft>
             </a:pPr>
             <a:r>
-              <a:rPr sz="1050" b="1" i="0">
+              <a:rPr sz="900" b="1" i="0">
                 <a:solidFill>
                   <a:srgbClr val="E6EDF3"/>
                 </a:solidFill>
-                <a:latin typeface="Consolas"/>
+                <a:latin typeface="Calibri"/>
               </a:rPr>
               <a:t>Not a VM</a:t>
             </a:r>
@@ -20235,22 +20252,20 @@
         <p:spPr>
           <a:xfrm>
             <a:off x="4800600" y="2267712"/>
-            <a:ext cx="3703320" cy="1572768"/>
-          </a:xfrm>
-          <a:prstGeom prst="rect">
-            <a:avLst/>
-          </a:prstGeom>
-          <a:noFill/>
-        </p:spPr>
-        <p:txBody>
-          <a:bodyPr wrap="none" lIns="25400" rIns="25400" tIns="25400" bIns="25400" anchor="t">
-            <a:spAutoFit/>
-          </a:bodyPr>
+            <a:ext cx="3703320" cy="1618488"/>
+          </a:xfrm>
+          <a:prstGeom prst="rect">
+            <a:avLst/>
+          </a:prstGeom>
+          <a:noFill/>
+        </p:spPr>
+        <p:txBody>
+          <a:bodyPr wrap="none" lIns="25400" rIns="25400" tIns="25400" bIns="25400" anchor="t"/>
           <a:lstStyle/>
           <a:p>
             <a:pPr algn="l">
               <a:lnSpc>
-                <a:spcPct val="112000"/>
+                <a:spcPct val="95000"/>
               </a:lnSpc>
               <a:spcBef>
                 <a:spcPts val="0"/>
@@ -20260,7 +20275,7 @@
               </a:spcAft>
             </a:pPr>
             <a:r>
-              <a:rPr sz="1050" b="0">
+              <a:rPr sz="900" b="0">
                 <a:solidFill>
                   <a:srgbClr val="E6EDF3"/>
                 </a:solidFill>
@@ -20272,7 +20287,7 @@
           <a:p>
             <a:pPr>
               <a:lnSpc>
-                <a:spcPct val="112000"/>
+                <a:spcPct val="95000"/>
               </a:lnSpc>
               <a:spcBef>
                 <a:spcPts val="0"/>
@@ -20282,7 +20297,7 @@
               </a:spcAft>
             </a:pPr>
             <a:r>
-              <a:rPr sz="1050" b="0">
+              <a:rPr sz="900" b="0">
                 <a:solidFill>
                   <a:srgbClr val="E6EDF3"/>
                 </a:solidFill>
@@ -20294,7 +20309,7 @@
           <a:p>
             <a:pPr>
               <a:lnSpc>
-                <a:spcPct val="112000"/>
+                <a:spcPct val="95000"/>
               </a:lnSpc>
               <a:spcBef>
                 <a:spcPts val="0"/>
@@ -20304,7 +20319,7 @@
               </a:spcAft>
             </a:pPr>
             <a:r>
-              <a:rPr sz="1050" b="0">
+              <a:rPr sz="900" b="0">
                 <a:solidFill>
                   <a:srgbClr val="E6EDF3"/>
                 </a:solidFill>
@@ -20316,7 +20331,7 @@
           <a:p>
             <a:pPr>
               <a:lnSpc>
-                <a:spcPct val="112000"/>
+                <a:spcPct val="95000"/>
               </a:lnSpc>
               <a:spcBef>
                 <a:spcPts val="0"/>
@@ -20326,7 +20341,7 @@
               </a:spcAft>
             </a:pPr>
             <a:r>
-              <a:rPr sz="1050" b="0">
+              <a:rPr sz="900" b="0">
                 <a:solidFill>
                   <a:srgbClr val="E6EDF3"/>
                 </a:solidFill>
@@ -20338,7 +20353,7 @@
           <a:p>
             <a:pPr>
               <a:lnSpc>
-                <a:spcPct val="112000"/>
+                <a:spcPct val="95000"/>
               </a:lnSpc>
               <a:spcBef>
                 <a:spcPts val="0"/>
@@ -20348,7 +20363,7 @@
               </a:spcAft>
             </a:pPr>
             <a:r>
-              <a:rPr sz="1050" b="0">
+              <a:rPr sz="900" b="0">
                 <a:solidFill>
                   <a:srgbClr val="E6EDF3"/>
                 </a:solidFill>
@@ -20360,7 +20375,7 @@
           <a:p>
             <a:pPr>
               <a:lnSpc>
-                <a:spcPct val="112000"/>
+                <a:spcPct val="95000"/>
               </a:lnSpc>
               <a:spcBef>
                 <a:spcPts val="0"/>
@@ -20370,7 +20385,7 @@
               </a:spcAft>
             </a:pPr>
             <a:r>
-              <a:rPr sz="1050" b="0">
+              <a:rPr sz="900" b="0">
                 <a:solidFill>
                   <a:srgbClr val="E6EDF3"/>
                 </a:solidFill>
@@ -20382,7 +20397,7 @@
           <a:p>
             <a:pPr>
               <a:lnSpc>
-                <a:spcPct val="112000"/>
+                <a:spcPct val="95000"/>
               </a:lnSpc>
               <a:spcBef>
                 <a:spcPts val="0"/>
@@ -20392,7 +20407,7 @@
               </a:spcAft>
             </a:pPr>
             <a:r>
-              <a:rPr sz="1050" b="0">
+              <a:rPr sz="900" b="0">
                 <a:solidFill>
                   <a:srgbClr val="E6EDF3"/>
                 </a:solidFill>
@@ -20404,7 +20419,7 @@
           <a:p>
             <a:pPr>
               <a:lnSpc>
-                <a:spcPct val="112000"/>
+                <a:spcPct val="95000"/>
               </a:lnSpc>
               <a:spcBef>
                 <a:spcPts val="0"/>
@@ -20414,7 +20429,7 @@
               </a:spcAft>
             </a:pPr>
             <a:r>
-              <a:rPr sz="1050" b="0">
+              <a:rPr sz="900" b="0">
                 <a:solidFill>
                   <a:srgbClr val="E6EDF3"/>
                 </a:solidFill>
@@ -20426,7 +20441,7 @@
           <a:p>
             <a:pPr>
               <a:lnSpc>
-                <a:spcPct val="112000"/>
+                <a:spcPct val="95000"/>
               </a:lnSpc>
               <a:spcBef>
                 <a:spcPts val="0"/>
@@ -20436,7 +20451,7 @@
               </a:spcAft>
             </a:pPr>
             <a:r>
-              <a:rPr sz="1050" b="0">
+              <a:rPr sz="900" b="0">
                 <a:solidFill>
                   <a:srgbClr val="E6EDF3"/>
                 </a:solidFill>
@@ -20448,7 +20463,7 @@
           <a:p>
             <a:pPr>
               <a:lnSpc>
-                <a:spcPct val="112000"/>
+                <a:spcPct val="95000"/>
               </a:lnSpc>
               <a:spcBef>
                 <a:spcPts val="0"/>
@@ -20458,7 +20473,7 @@
               </a:spcAft>
             </a:pPr>
             <a:r>
-              <a:rPr sz="1050" b="0">
+              <a:rPr sz="900" b="0">
                 <a:solidFill>
                   <a:srgbClr val="E6EDF3"/>
                 </a:solidFill>
@@ -20640,7 +20655,7 @@
               </a:spcAft>
             </a:pPr>
             <a:r>
-              <a:rPr sz="1050" b="0" i="0">
+              <a:rPr sz="900" b="0" i="0">
                 <a:solidFill>
                   <a:srgbClr val="E6EDF3"/>
                 </a:solidFill>
@@ -20773,7 +20788,7 @@
               </a:spcAft>
             </a:pPr>
             <a:r>
-              <a:rPr sz="1050" b="0" i="0">
+              <a:rPr sz="900" b="0" i="0">
                 <a:solidFill>
                   <a:srgbClr val="E6EDF3"/>
                 </a:solidFill>
@@ -20906,7 +20921,7 @@
               </a:spcAft>
             </a:pPr>
             <a:r>
-              <a:rPr sz="1050" b="0" i="0">
+              <a:rPr sz="900" b="0" i="0">
                 <a:solidFill>
                   <a:srgbClr val="E6EDF3"/>
                 </a:solidFill>
@@ -21017,7 +21032,7 @@
                 <a:ea typeface="Calibri" pitchFamily="34" charset="-122"/>
                 <a:cs typeface="Calibri" pitchFamily="34" charset="-120"/>
               </a:rPr>
-              <a:t>Source of Truth</a:t>
+              <a:t>Authority Order for SDK 1.0.13</a:t>
             </a:r>
             <a:endParaRPr lang="en-US" sz="2600" dirty="0"/>
           </a:p>
@@ -21349,7 +21364,7 @@
                 <a:ea typeface="Calibri" pitchFamily="34" charset="-122"/>
                 <a:cs typeface="Calibri" pitchFamily="34" charset="-120"/>
               </a:rPr>
-              <a:t>Exact signatures and wire shapes beat stale prose</a:t>
+              <a:t>Generated signatures and wire shapes define the installed API</a:t>
             </a:r>
             <a:endParaRPr lang="en-US" sz="1100" dirty="0"/>
           </a:p>
@@ -22399,7 +22414,7 @@
                 <a:ea typeface="Calibri" pitchFamily="34" charset="-122"/>
                 <a:cs typeface="Calibri" pitchFamily="34" charset="-120"/>
               </a:rPr>
-              <a:t>When prose disagrees, generated stable types and tests win.</a:t>
+              <a:t>When prose differs, use the generated stable types and tests.</a:t>
             </a:r>
             <a:endParaRPr lang="en-US" sz="1400" dirty="0"/>
           </a:p>
@@ -22516,7 +22531,7 @@
                 </a:solidFill>
                 <a:latin typeface="Calibri"/>
               </a:rPr>
-              <a:t>Build One Verified Path</a:t>
+              <a:t>Implementation Checklist</a:t>
             </a:r>
           </a:p>
         </p:txBody>
@@ -22558,7 +22573,7 @@
                 </a:solidFill>
                 <a:latin typeface="Calibri"/>
               </a:rPr>
-              <a:t>Understand the SDK, choose the right surface, then use the smallest sample that proves the behavior</a:t>
+              <a:t>Define runtime ownership, identity, tool scope, and evidence before adding capabilities</a:t>
             </a:r>
           </a:p>
         </p:txBody>
@@ -22646,7 +22661,7 @@
                 </a:solidFill>
                 <a:latin typeface="Calibri"/>
               </a:rPr>
-              <a:t>Learning path</a:t>
+              <a:t>Required decisions</a:t>
             </a:r>
           </a:p>
         </p:txBody>
@@ -22688,7 +22703,7 @@
                 </a:solidFill>
                 <a:latin typeface="Calibri"/>
               </a:rPr>
-              <a:t>1. Understand the SDK</a:t>
+              <a:t>1. Runtime connection</a:t>
             </a:r>
           </a:p>
         </p:txBody>
@@ -22730,7 +22745,7 @@
                 </a:solidFill>
                 <a:latin typeface="Calibri"/>
               </a:rPr>
-              <a:t>Runtime, lifecycle, events, tools, permissions</a:t>
+              <a:t>Managed child or protected existing runtime URI</a:t>
             </a:r>
           </a:p>
         </p:txBody>
@@ -22772,7 +22787,7 @@
                 </a:solidFill>
                 <a:latin typeface="Calibri"/>
               </a:rPr>
-              <a:t>2. Compare CLI and SDK</a:t>
+              <a:t>2. Identity and ownership</a:t>
             </a:r>
           </a:p>
         </p:txBody>
@@ -22814,7 +22829,7 @@
                 </a:solidFill>
                 <a:latin typeface="Calibri"/>
               </a:rPr>
-              <a:t>Interactive product versus application component</a:t>
+              <a:t>Authenticate principals; authorize session create, resume, and delete</a:t>
             </a:r>
           </a:p>
         </p:txBody>
@@ -22856,7 +22871,7 @@
                 </a:solidFill>
                 <a:latin typeface="Calibri"/>
               </a:rPr>
-              <a:t>3. Explore possibilities</a:t>
+              <a:t>3. Tool execution controls</a:t>
             </a:r>
           </a:p>
         </p:txBody>
@@ -22898,7 +22913,7 @@
                 </a:solidFill>
                 <a:latin typeface="Calibri"/>
               </a:rPr>
-              <a:t>Products, automation, services, and providers</a:t>
+              <a:t>ToolSet, permission callbacks, hooks, and sandbox policy</a:t>
             </a:r>
           </a:p>
         </p:txBody>
@@ -22940,7 +22955,7 @@
                 </a:solidFill>
                 <a:latin typeface="Calibri"/>
               </a:rPr>
-              <a:t>4. Build with samples</a:t>
+              <a:t>4. Runtime evidence</a:t>
             </a:r>
           </a:p>
         </p:txBody>
@@ -22982,7 +22997,7 @@
                 </a:solidFill>
                 <a:latin typeface="Calibri"/>
               </a:rPr>
-              <a:t>Eight runnable paths with visible evidence</a:t>
+              <a:t>Timeouts, errors, tool-call IDs, results, and audit events</a:t>
             </a:r>
           </a:p>
         </p:txBody>
@@ -23150,7 +23165,7 @@
                 </a:solidFill>
                 <a:latin typeface="Calibri"/>
               </a:rPr>
-              <a:t>Published stable types and tests beat stale prose</a:t>
+              <a:t>Use published stable types and tests when prose differs</a:t>
             </a:r>
           </a:p>
         </p:txBody>
@@ -23840,7 +23855,7 @@
                 <a:ea typeface="Calibri" pitchFamily="34" charset="-122"/>
                 <a:cs typeface="Calibri" pitchFamily="34" charset="-120"/>
               </a:rPr>
-              <a:t>Embed the same agent runtime behind Copilot CLI in your application.</a:t>
+              <a:t>The SDK exposes the Copilot runtime through language APIs.</a:t>
             </a:r>
             <a:endParaRPr lang="en-US" sz="1600" dirty="0"/>
           </a:p>
@@ -24335,7 +24350,7 @@
                 <a:ea typeface="Calibri" pitchFamily="34" charset="-122"/>
                 <a:cs typeface="Calibri" pitchFamily="34" charset="-120"/>
               </a:rPr>
-              <a:t>Extensible</a:t>
+              <a:t>Extension APIs</a:t>
             </a:r>
             <a:endParaRPr lang="en-US" sz="1400" dirty="0"/>
           </a:p>
@@ -26259,7 +26274,7 @@
                 <a:ea typeface="Calibri" pitchFamily="34" charset="-122"/>
                 <a:cs typeface="Calibri" pitchFamily="34" charset="-120"/>
               </a:rPr>
-              <a:t>Typed events carry progress; send_and_wait composes bounded completion</a:t>
+              <a:t>Typed events report progress; send_and_wait handles completion and errors</a:t>
             </a:r>
             <a:endParaRPr lang="en-US" sz="1200" dirty="0"/>
           </a:p>
@@ -26401,7 +26416,7 @@
               </a:spcAft>
             </a:pPr>
             <a:r>
-              <a:rPr sz="1200" b="0">
+              <a:rPr sz="1100" b="0">
                 <a:solidFill>
                   <a:srgbClr val="E6EDF3"/>
                 </a:solidFill>
@@ -26423,7 +26438,7 @@
               </a:spcAft>
             </a:pPr>
             <a:r>
-              <a:rPr sz="1200" b="0">
+              <a:rPr sz="1100" b="0">
                 <a:solidFill>
                   <a:srgbClr val="E6EDF3"/>
                 </a:solidFill>
@@ -26445,7 +26460,7 @@
               </a:spcAft>
             </a:pPr>
             <a:r>
-              <a:rPr sz="1200" b="0">
+              <a:rPr sz="1100" b="0">
                 <a:solidFill>
                   <a:srgbClr val="E6EDF3"/>
                 </a:solidFill>
@@ -26467,7 +26482,7 @@
               </a:spcAft>
             </a:pPr>
             <a:r>
-              <a:rPr sz="1200" b="0">
+              <a:rPr sz="1100" b="0">
                 <a:solidFill>
                   <a:srgbClr val="E6EDF3"/>
                 </a:solidFill>
@@ -26489,7 +26504,7 @@
               </a:spcAft>
             </a:pPr>
             <a:r>
-              <a:rPr sz="1200" b="0">
+              <a:rPr sz="1100" b="0">
                 <a:solidFill>
                   <a:srgbClr val="E6EDF3"/>
                 </a:solidFill>
@@ -26511,13 +26526,13 @@
               </a:spcAft>
             </a:pPr>
             <a:r>
-              <a:rPr sz="1200" b="0">
+              <a:rPr sz="1100" b="0">
                 <a:solidFill>
                   <a:srgbClr val="E6EDF3"/>
                 </a:solidFill>
                 <a:latin typeface="Courier New"/>
               </a:rPr>
-              <a:t xml:space="preserve">        case Delta(delta_content=text):</a:t>
+              <a:t xml:space="preserve">        case Delta(</a:t>
             </a:r>
           </a:p>
           <a:p>
@@ -26533,13 +26548,145 @@
               </a:spcAft>
             </a:pPr>
             <a:r>
-              <a:rPr sz="1200" b="0">
+              <a:rPr sz="1100" b="0">
                 <a:solidFill>
                   <a:srgbClr val="E6EDF3"/>
                 </a:solidFill>
                 <a:latin typeface="Courier New"/>
               </a:rPr>
-              <a:t xml:space="preserve">            print(text or "", end="", flush=True)</a:t>
+              <a:t xml:space="preserve">            delta_content=text</a:t>
+            </a:r>
+          </a:p>
+          <a:p>
+            <a:pPr>
+              <a:lnSpc>
+                <a:spcPct val="112000"/>
+              </a:lnSpc>
+              <a:spcBef>
+                <a:spcPts val="0"/>
+              </a:spcBef>
+              <a:spcAft>
+                <a:spcPts val="0"/>
+              </a:spcAft>
+            </a:pPr>
+            <a:r>
+              <a:rPr sz="1100" b="0">
+                <a:solidFill>
+                  <a:srgbClr val="E6EDF3"/>
+                </a:solidFill>
+                <a:latin typeface="Courier New"/>
+              </a:rPr>
+              <a:t xml:space="preserve">        ):</a:t>
+            </a:r>
+          </a:p>
+          <a:p>
+            <a:pPr>
+              <a:lnSpc>
+                <a:spcPct val="112000"/>
+              </a:lnSpc>
+              <a:spcBef>
+                <a:spcPts val="0"/>
+              </a:spcBef>
+              <a:spcAft>
+                <a:spcPts val="0"/>
+              </a:spcAft>
+            </a:pPr>
+            <a:r>
+              <a:rPr sz="1100" b="0">
+                <a:solidFill>
+                  <a:srgbClr val="E6EDF3"/>
+                </a:solidFill>
+                <a:latin typeface="Courier New"/>
+              </a:rPr>
+              <a:t xml:space="preserve">            print(</a:t>
+            </a:r>
+          </a:p>
+          <a:p>
+            <a:pPr>
+              <a:lnSpc>
+                <a:spcPct val="112000"/>
+              </a:lnSpc>
+              <a:spcBef>
+                <a:spcPts val="0"/>
+              </a:spcBef>
+              <a:spcAft>
+                <a:spcPts val="0"/>
+              </a:spcAft>
+            </a:pPr>
+            <a:r>
+              <a:rPr sz="1100" b="0">
+                <a:solidFill>
+                  <a:srgbClr val="E6EDF3"/>
+                </a:solidFill>
+                <a:latin typeface="Courier New"/>
+              </a:rPr>
+              <a:t xml:space="preserve">                text or "",</a:t>
+            </a:r>
+          </a:p>
+          <a:p>
+            <a:pPr>
+              <a:lnSpc>
+                <a:spcPct val="112000"/>
+              </a:lnSpc>
+              <a:spcBef>
+                <a:spcPts val="0"/>
+              </a:spcBef>
+              <a:spcAft>
+                <a:spcPts val="0"/>
+              </a:spcAft>
+            </a:pPr>
+            <a:r>
+              <a:rPr sz="1100" b="0">
+                <a:solidFill>
+                  <a:srgbClr val="E6EDF3"/>
+                </a:solidFill>
+                <a:latin typeface="Courier New"/>
+              </a:rPr>
+              <a:t xml:space="preserve">                end="",</a:t>
+            </a:r>
+          </a:p>
+          <a:p>
+            <a:pPr>
+              <a:lnSpc>
+                <a:spcPct val="112000"/>
+              </a:lnSpc>
+              <a:spcBef>
+                <a:spcPts val="0"/>
+              </a:spcBef>
+              <a:spcAft>
+                <a:spcPts val="0"/>
+              </a:spcAft>
+            </a:pPr>
+            <a:r>
+              <a:rPr sz="1100" b="0">
+                <a:solidFill>
+                  <a:srgbClr val="E6EDF3"/>
+                </a:solidFill>
+                <a:latin typeface="Courier New"/>
+              </a:rPr>
+              <a:t xml:space="preserve">                flush=True,</a:t>
+            </a:r>
+          </a:p>
+          <a:p>
+            <a:pPr>
+              <a:lnSpc>
+                <a:spcPct val="112000"/>
+              </a:lnSpc>
+              <a:spcBef>
+                <a:spcPts val="0"/>
+              </a:spcBef>
+              <a:spcAft>
+                <a:spcPts val="0"/>
+              </a:spcAft>
+            </a:pPr>
+            <a:r>
+              <a:rPr sz="1100" b="0">
+                <a:solidFill>
+                  <a:srgbClr val="E6EDF3"/>
+                </a:solidFill>
+                <a:latin typeface="Courier New"/>
+              </a:rPr>
+              <a:t xml:space="preserve">            )</a:t>
             </a:r>
           </a:p>
         </p:txBody>
@@ -26680,7 +26827,7 @@
               </a:spcAft>
             </a:pPr>
             <a:r>
-              <a:rPr sz="1200" b="0">
+              <a:rPr sz="1100" b="0">
                 <a:solidFill>
                   <a:srgbClr val="E6EDF3"/>
                 </a:solidFill>
@@ -26702,7 +26849,7 @@
               </a:spcAft>
             </a:pPr>
             <a:r>
-              <a:rPr sz="1200" b="0">
+              <a:rPr sz="1100" b="0">
                 <a:solidFill>
                   <a:srgbClr val="E6EDF3"/>
                 </a:solidFill>
@@ -26724,13 +26871,13 @@
               </a:spcAft>
             </a:pPr>
             <a:r>
-              <a:rPr sz="1200" b="0">
+              <a:rPr sz="1100" b="0">
                 <a:solidFill>
                   <a:srgbClr val="E6EDF3"/>
                 </a:solidFill>
                 <a:latin typeface="Courier New"/>
               </a:rPr>
-              <a:t xml:space="preserve">        streaming=True, available_tools=[])</a:t>
+              <a:t xml:space="preserve">        streaming=True,</a:t>
             </a:r>
           </a:p>
           <a:p>
@@ -26746,13 +26893,13 @@
               </a:spcAft>
             </a:pPr>
             <a:r>
-              <a:rPr sz="1200" b="0">
+              <a:rPr sz="1100" b="0">
                 <a:solidFill>
                   <a:srgbClr val="E6EDF3"/>
                 </a:solidFill>
                 <a:latin typeface="Courier New"/>
               </a:rPr>
-              <a:t xml:space="preserve">    unsubscribe = session.on(on_event)</a:t>
+              <a:t xml:space="preserve">        available_tools=[],</a:t>
             </a:r>
           </a:p>
           <a:p>
@@ -26768,13 +26915,13 @@
               </a:spcAft>
             </a:pPr>
             <a:r>
-              <a:rPr sz="1200" b="0">
+              <a:rPr sz="1100" b="0">
                 <a:solidFill>
                   <a:srgbClr val="E6EDF3"/>
                 </a:solidFill>
                 <a:latin typeface="Courier New"/>
               </a:rPr>
-              <a:t xml:space="preserve">    reply = await session.send_and_wait(</a:t>
+              <a:t xml:space="preserve">    )</a:t>
             </a:r>
           </a:p>
           <a:p>
@@ -26790,13 +26937,13 @@
               </a:spcAft>
             </a:pPr>
             <a:r>
-              <a:rPr sz="1200" b="0">
+              <a:rPr sz="1100" b="0">
                 <a:solidFill>
                   <a:srgbClr val="E6EDF3"/>
                 </a:solidFill>
                 <a:latin typeface="Courier New"/>
               </a:rPr>
-              <a:t xml:space="preserve">        "Explain the SDK briefly.", timeout=60)</a:t>
+              <a:t xml:space="preserve">    unsubscribe = session.on(on_event)</a:t>
             </a:r>
           </a:p>
           <a:p>
@@ -26812,13 +26959,13 @@
               </a:spcAft>
             </a:pPr>
             <a:r>
-              <a:rPr sz="1200" b="0">
+              <a:rPr sz="1100" b="0">
                 <a:solidFill>
                   <a:srgbClr val="E6EDF3"/>
                 </a:solidFill>
                 <a:latin typeface="Courier New"/>
               </a:rPr>
-              <a:t xml:space="preserve">    if reply is None:</a:t>
+              <a:t xml:space="preserve">    reply = await session.send_and_wait(</a:t>
             </a:r>
           </a:p>
           <a:p>
@@ -26834,13 +26981,13 @@
               </a:spcAft>
             </a:pPr>
             <a:r>
-              <a:rPr sz="1200" b="0">
+              <a:rPr sz="1100" b="0">
                 <a:solidFill>
                   <a:srgbClr val="E6EDF3"/>
                 </a:solidFill>
                 <a:latin typeface="Courier New"/>
               </a:rPr>
-              <a:t xml:space="preserve">        raise RuntimeError("No final message")</a:t>
+              <a:t xml:space="preserve">        "Explain the SDK briefly.",</a:t>
             </a:r>
           </a:p>
           <a:p>
@@ -26856,7 +27003,139 @@
               </a:spcAft>
             </a:pPr>
             <a:r>
-              <a:rPr sz="1200" b="0">
+              <a:rPr sz="1100" b="0">
+                <a:solidFill>
+                  <a:srgbClr val="E6EDF3"/>
+                </a:solidFill>
+                <a:latin typeface="Courier New"/>
+              </a:rPr>
+              <a:t xml:space="preserve">        timeout=60,</a:t>
+            </a:r>
+          </a:p>
+          <a:p>
+            <a:pPr>
+              <a:lnSpc>
+                <a:spcPct val="112000"/>
+              </a:lnSpc>
+              <a:spcBef>
+                <a:spcPts val="0"/>
+              </a:spcBef>
+              <a:spcAft>
+                <a:spcPts val="0"/>
+              </a:spcAft>
+            </a:pPr>
+            <a:r>
+              <a:rPr sz="1100" b="0">
+                <a:solidFill>
+                  <a:srgbClr val="E6EDF3"/>
+                </a:solidFill>
+                <a:latin typeface="Courier New"/>
+              </a:rPr>
+              <a:t xml:space="preserve">    )</a:t>
+            </a:r>
+          </a:p>
+          <a:p>
+            <a:pPr>
+              <a:lnSpc>
+                <a:spcPct val="112000"/>
+              </a:lnSpc>
+              <a:spcBef>
+                <a:spcPts val="0"/>
+              </a:spcBef>
+              <a:spcAft>
+                <a:spcPts val="0"/>
+              </a:spcAft>
+            </a:pPr>
+            <a:r>
+              <a:rPr sz="1100" b="0">
+                <a:solidFill>
+                  <a:srgbClr val="E6EDF3"/>
+                </a:solidFill>
+                <a:latin typeface="Courier New"/>
+              </a:rPr>
+              <a:t xml:space="preserve">    if reply is None:</a:t>
+            </a:r>
+          </a:p>
+          <a:p>
+            <a:pPr>
+              <a:lnSpc>
+                <a:spcPct val="112000"/>
+              </a:lnSpc>
+              <a:spcBef>
+                <a:spcPts val="0"/>
+              </a:spcBef>
+              <a:spcAft>
+                <a:spcPts val="0"/>
+              </a:spcAft>
+            </a:pPr>
+            <a:r>
+              <a:rPr sz="1100" b="0">
+                <a:solidFill>
+                  <a:srgbClr val="E6EDF3"/>
+                </a:solidFill>
+                <a:latin typeface="Courier New"/>
+              </a:rPr>
+              <a:t xml:space="preserve">        raise RuntimeError(</a:t>
+            </a:r>
+          </a:p>
+          <a:p>
+            <a:pPr>
+              <a:lnSpc>
+                <a:spcPct val="112000"/>
+              </a:lnSpc>
+              <a:spcBef>
+                <a:spcPts val="0"/>
+              </a:spcBef>
+              <a:spcAft>
+                <a:spcPts val="0"/>
+              </a:spcAft>
+            </a:pPr>
+            <a:r>
+              <a:rPr sz="1100" b="0">
+                <a:solidFill>
+                  <a:srgbClr val="E6EDF3"/>
+                </a:solidFill>
+                <a:latin typeface="Courier New"/>
+              </a:rPr>
+              <a:t xml:space="preserve">            "No final message"</a:t>
+            </a:r>
+          </a:p>
+          <a:p>
+            <a:pPr>
+              <a:lnSpc>
+                <a:spcPct val="112000"/>
+              </a:lnSpc>
+              <a:spcBef>
+                <a:spcPts val="0"/>
+              </a:spcBef>
+              <a:spcAft>
+                <a:spcPts val="0"/>
+              </a:spcAft>
+            </a:pPr>
+            <a:r>
+              <a:rPr sz="1100" b="0">
+                <a:solidFill>
+                  <a:srgbClr val="E6EDF3"/>
+                </a:solidFill>
+                <a:latin typeface="Courier New"/>
+              </a:rPr>
+              <a:t xml:space="preserve">        )</a:t>
+            </a:r>
+          </a:p>
+          <a:p>
+            <a:pPr>
+              <a:lnSpc>
+                <a:spcPct val="112000"/>
+              </a:lnSpc>
+              <a:spcBef>
+                <a:spcPts val="0"/>
+              </a:spcBef>
+              <a:spcAft>
+                <a:spcPts val="0"/>
+              </a:spcAft>
+            </a:pPr>
+            <a:r>
+              <a:rPr sz="1100" b="0">
                 <a:solidFill>
                   <a:srgbClr val="E6EDF3"/>
                 </a:solidFill>
@@ -28296,7 +28575,7 @@
                 </a:solidFill>
                 <a:latin typeface="Calibri"/>
               </a:rPr>
-              <a:t>Exposure is not approval. Approval is not containment.</a:t>
+              <a:t>Tool exposure, authorization, and containment are independent controls.</a:t>
             </a:r>
           </a:p>
         </p:txBody>
@@ -28600,13 +28879,57 @@
               </a:spcAft>
             </a:pPr>
             <a:r>
-              <a:rPr sz="1250" b="0">
+              <a:rPr sz="1200" b="0">
                 <a:solidFill>
                   <a:srgbClr val="E6EDF3"/>
                 </a:solidFill>
                 <a:latin typeface="Courier New"/>
               </a:rPr>
-              <a:t>ToolSet().add_builtin("view")</a:t>
+              <a:t>ToolSet().add_builtin(</a:t>
+            </a:r>
+          </a:p>
+          <a:p>
+            <a:pPr>
+              <a:lnSpc>
+                <a:spcPct val="112000"/>
+              </a:lnSpc>
+              <a:spcBef>
+                <a:spcPts val="0"/>
+              </a:spcBef>
+              <a:spcAft>
+                <a:spcPts val="0"/>
+              </a:spcAft>
+            </a:pPr>
+            <a:r>
+              <a:rPr sz="1200" b="0">
+                <a:solidFill>
+                  <a:srgbClr val="E6EDF3"/>
+                </a:solidFill>
+                <a:latin typeface="Courier New"/>
+              </a:rPr>
+              <a:t xml:space="preserve">    "view"</a:t>
+            </a:r>
+          </a:p>
+          <a:p>
+            <a:pPr>
+              <a:lnSpc>
+                <a:spcPct val="112000"/>
+              </a:lnSpc>
+              <a:spcBef>
+                <a:spcPts val="0"/>
+              </a:spcBef>
+              <a:spcAft>
+                <a:spcPts val="0"/>
+              </a:spcAft>
+            </a:pPr>
+            <a:r>
+              <a:rPr sz="1200" b="0">
+                <a:solidFill>
+                  <a:srgbClr val="E6EDF3"/>
+                </a:solidFill>
+                <a:latin typeface="Courier New"/>
+              </a:rPr>
+              <a:t>)</a:t>
             </a:r>
           </a:p>
         </p:txBody>
@@ -29264,13 +29587,13 @@
               </a:spcAft>
             </a:pPr>
             <a:r>
-              <a:rPr sz="1250" b="0">
+              <a:rPr sz="1200" b="0">
                 <a:solidFill>
                   <a:srgbClr val="E6EDF3"/>
                 </a:solidFill>
                 <a:latin typeface="Courier New"/>
               </a:rPr>
-              <a:t>SandboxConfig(enabled=True,</a:t>
+              <a:t>SandboxConfig(</a:t>
             </a:r>
           </a:p>
           <a:p>
@@ -29286,13 +29609,57 @@
               </a:spcAft>
             </a:pPr>
             <a:r>
-              <a:rPr sz="1250" b="0">
+              <a:rPr sz="1200" b="0">
                 <a:solidFill>
                   <a:srgbClr val="E6EDF3"/>
                 </a:solidFill>
                 <a:latin typeface="Courier New"/>
               </a:rPr>
-              <a:t xml:space="preserve">              allow_bypass=False)</a:t>
+              <a:t xml:space="preserve">    enabled=True,</a:t>
+            </a:r>
+          </a:p>
+          <a:p>
+            <a:pPr>
+              <a:lnSpc>
+                <a:spcPct val="112000"/>
+              </a:lnSpc>
+              <a:spcBef>
+                <a:spcPts val="0"/>
+              </a:spcBef>
+              <a:spcAft>
+                <a:spcPts val="0"/>
+              </a:spcAft>
+            </a:pPr>
+            <a:r>
+              <a:rPr sz="1200" b="0">
+                <a:solidFill>
+                  <a:srgbClr val="E6EDF3"/>
+                </a:solidFill>
+                <a:latin typeface="Courier New"/>
+              </a:rPr>
+              <a:t xml:space="preserve">    allow_bypass=False,</a:t>
+            </a:r>
+          </a:p>
+          <a:p>
+            <a:pPr>
+              <a:lnSpc>
+                <a:spcPct val="112000"/>
+              </a:lnSpc>
+              <a:spcBef>
+                <a:spcPts val="0"/>
+              </a:spcBef>
+              <a:spcAft>
+                <a:spcPts val="0"/>
+              </a:spcAft>
+            </a:pPr>
+            <a:r>
+              <a:rPr sz="1200" b="0">
+                <a:solidFill>
+                  <a:srgbClr val="E6EDF3"/>
+                </a:solidFill>
+                <a:latin typeface="Courier New"/>
+              </a:rPr>
+              <a:t>)</a:t>
             </a:r>
           </a:p>
         </p:txBody>
@@ -29451,7 +29818,7 @@
                 </a:solidFill>
                 <a:latin typeface="Calibri"/>
               </a:rPr>
-              <a:t>Same runtime engine and JSON-RPC protocol; different product boundary</a:t>
+              <a:t>Same runtime and JSON-RPC protocol; different UI, lifecycle, and ownership</a:t>
             </a:r>
           </a:p>
         </p:txBody>

</xml_diff>